<commit_message>
fixed 14 agian and starting 15
</commit_message>
<xml_diff>
--- a/docs/ecostats_lectures/lecture_15/15_01_lecture_powerpoint.pptx
+++ b/docs/ecostats_lectures/lecture_15/15_01_lecture_powerpoint.pptx
@@ -4799,7 +4799,7 @@
                         <a:buNone/>
                       </a:pPr>
                       <a:r>
-                        <a:rPr cap="none" sz="1000" i="0" b="1" u="none">
+                        <a:rPr cap="none" sz="1000" i="0" b="1" u="none" strike="noStrike">
                           <a:solidFill>
                             <a:srgbClr val="000000">
                               <a:alpha val="100000"/>
@@ -4864,7 +4864,7 @@
                         <a:buNone/>
                       </a:pPr>
                       <a:r>
-                        <a:rPr cap="none" sz="1000" i="0" b="1" u="none">
+                        <a:rPr cap="none" sz="1000" i="0" b="1" u="none" strike="noStrike">
                           <a:solidFill>
                             <a:srgbClr val="000000">
                               <a:alpha val="100000"/>
@@ -4929,7 +4929,7 @@
                         <a:buNone/>
                       </a:pPr>
                       <a:r>
-                        <a:rPr cap="none" sz="1000" i="0" b="1" u="none">
+                        <a:rPr cap="none" sz="1000" i="0" b="1" u="none" strike="noStrike">
                           <a:solidFill>
                             <a:srgbClr val="000000">
                               <a:alpha val="100000"/>
@@ -4994,7 +4994,7 @@
                         <a:buNone/>
                       </a:pPr>
                       <a:r>
-                        <a:rPr cap="none" sz="1000" i="0" b="1" u="none">
+                        <a:rPr cap="none" sz="1000" i="0" b="1" u="none" strike="noStrike">
                           <a:solidFill>
                             <a:srgbClr val="000000">
                               <a:alpha val="100000"/>
@@ -5059,7 +5059,7 @@
                         <a:buNone/>
                       </a:pPr>
                       <a:r>
-                        <a:rPr cap="none" sz="1000" i="0" b="1" u="none">
+                        <a:rPr cap="none" sz="1000" i="0" b="1" u="none" strike="noStrike">
                           <a:solidFill>
                             <a:srgbClr val="000000">
                               <a:alpha val="100000"/>
@@ -5124,7 +5124,7 @@
                         <a:buNone/>
                       </a:pPr>
                       <a:r>
-                        <a:rPr cap="none" sz="1000" i="0" b="1" u="none">
+                        <a:rPr cap="none" sz="1000" i="0" b="1" u="none" strike="noStrike">
                           <a:solidFill>
                             <a:srgbClr val="000000">
                               <a:alpha val="100000"/>
@@ -5191,7 +5191,7 @@
                         <a:buNone/>
                       </a:pPr>
                       <a:r>
-                        <a:rPr cap="none" sz="1000" i="0" b="0" u="none">
+                        <a:rPr cap="none" sz="1000" i="0" b="0" u="none" strike="noStrike">
                           <a:solidFill>
                             <a:srgbClr val="000000">
                               <a:alpha val="100000"/>
@@ -5252,7 +5252,7 @@
                         <a:buNone/>
                       </a:pPr>
                       <a:r>
-                        <a:rPr cap="none" sz="1000" i="0" b="0" u="none">
+                        <a:rPr cap="none" sz="1000" i="0" b="0" u="none" strike="noStrike">
                           <a:solidFill>
                             <a:srgbClr val="000000">
                               <a:alpha val="100000"/>
@@ -5313,7 +5313,7 @@
                         <a:buNone/>
                       </a:pPr>
                       <a:r>
-                        <a:rPr cap="none" sz="1000" i="0" b="0" u="none">
+                        <a:rPr cap="none" sz="1000" i="0" b="0" u="none" strike="noStrike">
                           <a:solidFill>
                             <a:srgbClr val="000000">
                               <a:alpha val="100000"/>
@@ -5374,7 +5374,7 @@
                         <a:buNone/>
                       </a:pPr>
                       <a:r>
-                        <a:rPr cap="none" sz="1000" i="0" b="0" u="none">
+                        <a:rPr cap="none" sz="1000" i="0" b="0" u="none" strike="noStrike">
                           <a:solidFill>
                             <a:srgbClr val="000000">
                               <a:alpha val="100000"/>
@@ -5435,7 +5435,7 @@
                         <a:buNone/>
                       </a:pPr>
                       <a:r>
-                        <a:rPr cap="none" sz="1000" i="0" b="0" u="none">
+                        <a:rPr cap="none" sz="1000" i="0" b="0" u="none" strike="noStrike">
                           <a:solidFill>
                             <a:srgbClr val="000000">
                               <a:alpha val="100000"/>
@@ -5496,7 +5496,7 @@
                         <a:buNone/>
                       </a:pPr>
                       <a:r>
-                        <a:rPr cap="none" sz="1000" i="0" b="0" u="none">
+                        <a:rPr cap="none" sz="1000" i="0" b="0" u="none" strike="noStrike">
                           <a:solidFill>
                             <a:srgbClr val="000000">
                               <a:alpha val="100000"/>
@@ -5559,7 +5559,7 @@
                         <a:buNone/>
                       </a:pPr>
                       <a:r>
-                        <a:rPr cap="none" sz="1000" i="0" b="0" u="none">
+                        <a:rPr cap="none" sz="1000" i="0" b="0" u="none" strike="noStrike">
                           <a:solidFill>
                             <a:srgbClr val="000000">
                               <a:alpha val="100000"/>
@@ -5624,7 +5624,7 @@
                         <a:buNone/>
                       </a:pPr>
                       <a:r>
-                        <a:rPr cap="none" sz="1000" i="0" b="0" u="none">
+                        <a:rPr cap="none" sz="1000" i="0" b="0" u="none" strike="noStrike">
                           <a:solidFill>
                             <a:srgbClr val="000000">
                               <a:alpha val="100000"/>
@@ -5689,7 +5689,7 @@
                         <a:buNone/>
                       </a:pPr>
                       <a:r>
-                        <a:rPr cap="none" sz="1000" i="0" b="0" u="none">
+                        <a:rPr cap="none" sz="1000" i="0" b="0" u="none" strike="noStrike">
                           <a:solidFill>
                             <a:srgbClr val="000000">
                               <a:alpha val="100000"/>
@@ -5754,7 +5754,7 @@
                         <a:buNone/>
                       </a:pPr>
                       <a:r>
-                        <a:rPr cap="none" sz="1000" i="0" b="0" u="none">
+                        <a:rPr cap="none" sz="1000" i="0" b="0" u="none" strike="noStrike">
                           <a:solidFill>
                             <a:srgbClr val="000000">
                               <a:alpha val="100000"/>
@@ -5819,7 +5819,7 @@
                         <a:buNone/>
                       </a:pPr>
                       <a:r>
-                        <a:rPr cap="none" sz="1000" i="0" b="0" u="none">
+                        <a:rPr cap="none" sz="1000" i="0" b="0" u="none" strike="noStrike">
                           <a:solidFill>
                             <a:srgbClr val="000000">
                               <a:alpha val="100000"/>
@@ -5884,7 +5884,7 @@
                         <a:buNone/>
                       </a:pPr>
                       <a:r>
-                        <a:rPr cap="none" sz="1000" i="0" b="0" u="none">
+                        <a:rPr cap="none" sz="1000" i="0" b="0" u="none" strike="noStrike">
                           <a:solidFill>
                             <a:srgbClr val="000000">
                               <a:alpha val="100000"/>
@@ -5951,7 +5951,7 @@
                         <a:buNone/>
                       </a:pPr>
                       <a:r>
-                        <a:rPr cap="none" sz="1000" i="0" b="0" u="none">
+                        <a:rPr cap="none" sz="1000" i="0" b="0" u="none" strike="noStrike">
                           <a:solidFill>
                             <a:srgbClr val="000000">
                               <a:alpha val="100000"/>
@@ -6016,7 +6016,7 @@
                         <a:buNone/>
                       </a:pPr>
                       <a:r>
-                        <a:rPr cap="none" sz="1000" i="0" b="0" u="none">
+                        <a:rPr cap="none" sz="1000" i="0" b="0" u="none" strike="noStrike">
                           <a:solidFill>
                             <a:srgbClr val="000000">
                               <a:alpha val="100000"/>
@@ -6081,7 +6081,7 @@
                         <a:buNone/>
                       </a:pPr>
                       <a:r>
-                        <a:rPr cap="none" sz="1000" i="0" b="0" u="none">
+                        <a:rPr cap="none" sz="1000" i="0" b="0" u="none" strike="noStrike">
                           <a:solidFill>
                             <a:srgbClr val="000000">
                               <a:alpha val="100000"/>
@@ -6146,7 +6146,7 @@
                         <a:buNone/>
                       </a:pPr>
                       <a:r>
-                        <a:rPr cap="none" sz="1000" i="0" b="0" u="none">
+                        <a:rPr cap="none" sz="1000" i="0" b="0" u="none" strike="noStrike">
                           <a:solidFill>
                             <a:srgbClr val="000000">
                               <a:alpha val="100000"/>
@@ -6210,7 +6210,7 @@
                         </a:spcAft>
                         <a:buNone/>
                       </a:pPr>
-                      <a:endParaRPr cap="none" sz="1000" i="0" b="0" u="none">
+                      <a:endParaRPr cap="none" sz="1000" i="0" b="0" u="none" strike="noStrike">
                         <a:solidFill>
                           <a:srgbClr val="000000">
                             <a:alpha val="100000"/>
@@ -6222,7 +6222,7 @@
                         <a:sym typeface="Helvetica"/>
                       </a:endParaRPr>
                       <a:r>
-                        <a:rPr cap="none" sz="1000" i="0" b="0" u="none">
+                        <a:rPr cap="none" sz="1000" i="0" b="0" u="none" strike="noStrike">
                           <a:solidFill>
                             <a:srgbClr val="000000">
                               <a:alpha val="100000"/>
@@ -6287,7 +6287,7 @@
                         <a:buNone/>
                       </a:pPr>
                       <a:r>
-                        <a:rPr cap="none" sz="1000" i="0" b="0" u="none">
+                        <a:rPr cap="none" sz="1000" i="0" b="0" u="none" strike="noStrike">
                           <a:solidFill>
                             <a:srgbClr val="000000">
                               <a:alpha val="100000"/>
@@ -6354,7 +6354,7 @@
                         <a:buNone/>
                       </a:pPr>
                       <a:r>
-                        <a:rPr cap="none" sz="1000" i="0" b="0" u="none">
+                        <a:rPr cap="none" sz="1000" i="0" b="0" u="none" strike="noStrike">
                           <a:solidFill>
                             <a:srgbClr val="000000">
                               <a:alpha val="100000"/>
@@ -6419,7 +6419,7 @@
                         <a:buNone/>
                       </a:pPr>
                       <a:r>
-                        <a:rPr cap="none" sz="1000" i="0" b="0" u="none">
+                        <a:rPr cap="none" sz="1000" i="0" b="0" u="none" strike="noStrike">
                           <a:solidFill>
                             <a:srgbClr val="000000">
                               <a:alpha val="100000"/>
@@ -6484,7 +6484,7 @@
                         <a:buNone/>
                       </a:pPr>
                       <a:r>
-                        <a:rPr cap="none" sz="1000" i="0" b="0" u="none">
+                        <a:rPr cap="none" sz="1000" i="0" b="0" u="none" strike="noStrike">
                           <a:solidFill>
                             <a:srgbClr val="000000">
                               <a:alpha val="100000"/>
@@ -6548,7 +6548,7 @@
                         </a:spcAft>
                         <a:buNone/>
                       </a:pPr>
-                      <a:endParaRPr cap="none" sz="1000" i="0" b="0" u="none">
+                      <a:endParaRPr cap="none" sz="1000" i="0" b="0" u="none" strike="noStrike">
                         <a:solidFill>
                           <a:srgbClr val="000000">
                             <a:alpha val="100000"/>
@@ -6560,7 +6560,7 @@
                         <a:sym typeface="Helvetica"/>
                       </a:endParaRPr>
                       <a:r>
-                        <a:rPr cap="none" sz="1000" i="0" b="0" u="none">
+                        <a:rPr cap="none" sz="1000" i="0" b="0" u="none" strike="noStrike">
                           <a:solidFill>
                             <a:srgbClr val="000000">
                               <a:alpha val="100000"/>
@@ -6624,7 +6624,7 @@
                         </a:spcAft>
                         <a:buNone/>
                       </a:pPr>
-                      <a:endParaRPr cap="none" sz="1000" i="0" b="0" u="none">
+                      <a:endParaRPr cap="none" sz="1000" i="0" b="0" u="none" strike="noStrike">
                         <a:solidFill>
                           <a:srgbClr val="000000">
                             <a:alpha val="100000"/>
@@ -6636,7 +6636,7 @@
                         <a:sym typeface="Helvetica"/>
                       </a:endParaRPr>
                       <a:r>
-                        <a:rPr cap="none" sz="1000" i="0" b="0" u="none">
+                        <a:rPr cap="none" sz="1000" i="0" b="0" u="none" strike="noStrike">
                           <a:solidFill>
                             <a:srgbClr val="000000">
                               <a:alpha val="100000"/>
@@ -6700,7 +6700,7 @@
                         </a:spcAft>
                         <a:buNone/>
                       </a:pPr>
-                      <a:endParaRPr cap="none" sz="1000" i="0" b="0" u="none">
+                      <a:endParaRPr cap="none" sz="1000" i="0" b="0" u="none" strike="noStrike">
                         <a:solidFill>
                           <a:srgbClr val="000000">
                             <a:alpha val="100000"/>
@@ -6712,7 +6712,7 @@
                         <a:sym typeface="Helvetica"/>
                       </a:endParaRPr>
                       <a:r>
-                        <a:rPr cap="none" sz="1000" i="0" b="0" u="none">
+                        <a:rPr cap="none" sz="1000" i="0" b="0" u="none" strike="noStrike">
                           <a:solidFill>
                             <a:srgbClr val="000000">
                               <a:alpha val="100000"/>
@@ -9076,44 +9076,42 @@
             </a:r>
           </a:p>
           <a:p>
-            <a:pPr lvl="0" indent="0" marL="0">
-              <a:buNone/>
-            </a:pPr>
-            <a:r>
-              <a:rPr/>
-              <a:t>General Linearized Models (GLM)</a:t>
-            </a:r>
-          </a:p>
-          <a:p>
             <a:pPr lvl="0"/>
             <a:r>
               <a:rPr/>
+              <a:t>General Linear Models (GLM)</a:t>
+            </a:r>
+          </a:p>
+          <a:p>
+            <a:pPr lvl="1"/>
+            <a:r>
+              <a:rPr/>
               <a:t>Gaussian GLMs (normal distribution)</a:t>
             </a:r>
           </a:p>
           <a:p>
-            <a:pPr lvl="0"/>
+            <a:pPr lvl="1"/>
             <a:r>
               <a:rPr/>
               <a:t>Poisson GLMs (count data)</a:t>
             </a:r>
           </a:p>
           <a:p>
-            <a:pPr lvl="0"/>
+            <a:pPr lvl="1"/>
             <a:r>
               <a:rPr/>
               <a:t>Logistic GLMs (binary outcomes)</a:t>
             </a:r>
           </a:p>
           <a:p>
-            <a:pPr lvl="0"/>
+            <a:pPr lvl="1"/>
             <a:r>
               <a:rPr/>
               <a:t>Model assumptions and diagnostics</a:t>
             </a:r>
           </a:p>
           <a:p>
-            <a:pPr lvl="0"/>
+            <a:pPr lvl="1"/>
             <a:r>
               <a:rPr/>
               <a:t>Connection to ANOVA and linear models</a:t>
@@ -12350,79 +12348,77 @@
             </a:r>
           </a:p>
           <a:p>
-            <a:pPr lvl="0" indent="0" marL="0">
-              <a:buNone/>
-            </a:pPr>
+            <a:pPr lvl="0"/>
             <a:r>
               <a:rPr/>
               <a:t>Analysis of covariance (ANCOVA):</a:t>
             </a:r>
           </a:p>
           <a:p>
-            <a:pPr lvl="0"/>
+            <a:pPr lvl="1"/>
             <a:r>
               <a:rPr/>
               <a:t>Introduction to ANCOVA</a:t>
             </a:r>
           </a:p>
           <a:p>
-            <a:pPr lvl="0"/>
+            <a:pPr lvl="1"/>
             <a:r>
               <a:rPr/>
               <a:t>When to use ANCOVA</a:t>
             </a:r>
           </a:p>
           <a:p>
-            <a:pPr lvl="0"/>
+            <a:pPr lvl="1"/>
             <a:r>
               <a:rPr/>
               <a:t>Linear model for ANCOVA</a:t>
             </a:r>
           </a:p>
           <a:p>
-            <a:pPr lvl="0"/>
+            <a:pPr lvl="1"/>
             <a:r>
               <a:rPr/>
               <a:t>Analysis of variance in ANCOVA</a:t>
             </a:r>
           </a:p>
           <a:p>
-            <a:pPr lvl="0"/>
+            <a:pPr lvl="1"/>
             <a:r>
               <a:rPr/>
               <a:t>Assumptions of ANCOVA</a:t>
             </a:r>
           </a:p>
           <a:p>
+            <a:pPr lvl="2"/>
+            <a:r>
+              <a:rPr/>
+              <a:t>Homogeneous slopes</a:t>
+            </a:r>
+          </a:p>
+          <a:p>
             <a:pPr lvl="1"/>
             <a:r>
               <a:rPr/>
-              <a:t>Homogeneous slopes</a:t>
-            </a:r>
-          </a:p>
-          <a:p>
-            <a:pPr lvl="0"/>
-            <a:r>
-              <a:rPr/>
               <a:t>Robust ANCOVA approaches</a:t>
             </a:r>
           </a:p>
           <a:p>
-            <a:pPr lvl="0"/>
+            <a:pPr lvl="1"/>
             <a:r>
               <a:rPr/>
               <a:t>Specific comparisons of means</a:t>
             </a:r>
           </a:p>
           <a:p>
-            <a:pPr lvl="0"/>
+            <a:pPr lvl="1"/>
             <a:r>
               <a:rPr/>
               <a:t>Examples and interpretation</a:t>
             </a:r>
           </a:p>
           <a:p>
-            <a:pPr lvl="0"/>
+            <a:pPr lvl="1"/>
             <a:r>
               <a:rPr/>
               <a:t>Scientific reporting of ANCOVA results</a:t>
@@ -12956,14 +12952,28 @@
             <a:pPr lvl="0"/>
             <a:r>
               <a:rPr/>
-              <a:t>Common use: compare means of factor levels (groups), adjusting for variance from continuous covariate</a:t>
+              <a:t>Common use:</a:t>
+            </a:r>
+          </a:p>
+          <a:p>
+            <a:pPr lvl="1"/>
+            <a:r>
+              <a:rPr/>
+              <a:t>compare means of factor levels (groups), adjusting for variance from continuous covariate</a:t>
             </a:r>
           </a:p>
           <a:p>
             <a:pPr lvl="0"/>
             <a:r>
               <a:rPr/>
-              <a:t>Another use: determine whether two or more regression lines differ in slopes and intercepts</a:t>
+              <a:t>Another use:</a:t>
+            </a:r>
+          </a:p>
+          <a:p>
+            <a:pPr lvl="1"/>
+            <a:r>
+              <a:rPr/>
+              <a:t>determine whether two or more regression lines differ in slopes and intercepts</a:t>
             </a:r>
           </a:p>
         </p:txBody>
@@ -13223,62 +13233,56 @@
             </a:r>
           </a:p>
           <a:p>
-            <a:pPr lvl="0" indent="0" marL="0">
-              <a:buNone/>
-            </a:pPr>
+            <a:pPr lvl="0"/>
             <a:r>
               <a:rPr/>
               <a:t>Want to compare chirping rate of two cricket species:</a:t>
             </a:r>
           </a:p>
           <a:p>
-            <a:pPr lvl="0"/>
+            <a:pPr lvl="1"/>
             <a:r>
               <a:rPr i="1"/>
               <a:t>Oecanthus exclamationis</a:t>
             </a:r>
           </a:p>
           <a:p>
-            <a:pPr lvl="0"/>
+            <a:pPr lvl="1"/>
             <a:r>
               <a:rPr i="1"/>
               <a:t>Oecanthus niveus</a:t>
             </a:r>
           </a:p>
           <a:p>
-            <a:pPr lvl="0" indent="0" marL="0">
-              <a:buNone/>
-            </a:pPr>
+            <a:pPr lvl="0"/>
             <a:r>
               <a:rPr/>
               <a:t>But:</a:t>
             </a:r>
           </a:p>
           <a:p>
+            <a:pPr lvl="1"/>
+            <a:r>
+              <a:rPr/>
+              <a:t>Measured rates at different temperatures</a:t>
+            </a:r>
+          </a:p>
+          <a:p>
+            <a:pPr lvl="1"/>
+            <a:r>
+              <a:rPr/>
+              <a:t>Range of temperatures differed between species</a:t>
+            </a:r>
+          </a:p>
+          <a:p>
+            <a:pPr lvl="1"/>
+            <a:r>
+              <a:rPr/>
+              <a:t>Apparent relationship between pulse rate and temperature</a:t>
+            </a:r>
+          </a:p>
+          <a:p>
             <a:pPr lvl="0"/>
-            <a:r>
-              <a:rPr/>
-              <a:t>Measured rates at different temperatures</a:t>
-            </a:r>
-          </a:p>
-          <a:p>
-            <a:pPr lvl="0"/>
-            <a:r>
-              <a:rPr/>
-              <a:t>Range of temperatures differed between species</a:t>
-            </a:r>
-          </a:p>
-          <a:p>
-            <a:pPr lvl="0"/>
-            <a:r>
-              <a:rPr/>
-              <a:t>Apparent relationship between pulse rate and temperature</a:t>
-            </a:r>
-          </a:p>
-          <a:p>
-            <a:pPr lvl="0" indent="0" marL="0">
-              <a:buNone/>
-            </a:pPr>
             <a:r>
               <a:rPr/>
               <a:t>ANCOVA lets us adjust for temperature effect to get a more powerful test!</a:t>
@@ -13302,8 +13306,8 @@
         </p:blipFill>
         <p:spPr bwMode="auto">
           <a:xfrm>
-            <a:off x="6121400" y="1498600"/>
-            <a:ext cx="2781300" cy="2781300"/>
+            <a:off x="6121400" y="2044700"/>
+            <a:ext cx="2781300" cy="1714500"/>
           </a:xfrm>
           <a:prstGeom prst="rect">
             <a:avLst/>
@@ -13395,58 +13399,73 @@
             </a:r>
           </a:p>
           <a:p>
-            <a:pPr lvl="0" indent="0" marL="0">
-              <a:buNone/>
-            </a:pPr>
+            <a:pPr lvl="0"/>
             <a:r>
               <a:rPr/>
               <a:t>Key concept in ANCOVA: the difference between “unadjusted” group means and “adjusted” means.</a:t>
             </a:r>
           </a:p>
           <a:p>
-            <a:pPr lvl="0" indent="0" marL="0">
-              <a:buNone/>
-            </a:pPr>
+            <a:pPr lvl="0"/>
             <a:r>
               <a:rPr/>
               <a:t>In this visualization:</a:t>
             </a:r>
           </a:p>
           <a:p>
+            <a:pPr lvl="1"/>
+            <a:r>
+              <a:rPr/>
+              <a:t>Group Means (asterisks): unadjusted means for each group</a:t>
+            </a:r>
+          </a:p>
+          <a:p>
+            <a:pPr lvl="2"/>
+            <a:r>
+              <a:rPr/>
+              <a:t>average X value and average Y value for all points in that group.</a:t>
+            </a:r>
+          </a:p>
+          <a:p>
+            <a:pPr lvl="3"/>
+            <a:r>
+              <a:rPr/>
+              <a:t>Group A and Group B have different mean X values - different points along the X axis</a:t>
+            </a:r>
+          </a:p>
+          <a:p>
+            <a:pPr lvl="1"/>
+            <a:r>
+              <a:rPr/>
+              <a:t>Adjusted Means (triangles): What ANCOVA actually compares</a:t>
+            </a:r>
+          </a:p>
+          <a:p>
+            <a:pPr lvl="1"/>
+            <a:r>
+              <a:rPr/>
+              <a:t>adjusted means represent group’s mean if all groups had same value of covariate (overall mean X).</a:t>
+            </a:r>
+          </a:p>
+          <a:p>
             <a:pPr lvl="0"/>
             <a:r>
               <a:rPr/>
-              <a:t>Group Means (shown as asterisks): raw/unadjusted means for each group - simply the average X value and average Y value for all points in that group. Notice that Group A and Group B have different mean X values (they’re positioned at different points along the X axis).</a:t>
-            </a:r>
-          </a:p>
-          <a:p>
-            <a:pPr lvl="0"/>
-            <a:r>
-              <a:rPr/>
-              <a:t>Adjusted Means (shown as triangles): These are what ANCOVA actually compares. The adjusted means represent what each group’s mean would be if all groups had the same value of the covariate (in this case, the overall mean X).</a:t>
-            </a:r>
-          </a:p>
-          <a:p>
-            <a:pPr lvl="0" indent="0" marL="0">
-              <a:buNone/>
-            </a:pPr>
-            <a:r>
-              <a:rPr/>
-              <a:t>The core purpose of ANCOVA is to make this adjustment. This is important because:</a:t>
-            </a:r>
-          </a:p>
-          <a:p>
-            <a:pPr lvl="0"/>
-            <a:r>
-              <a:rPr/>
-              <a:t>When groups differ in their covariate values (as they often do in observational studies or even in experiments with random assignment), comparing raw means can be misleading</a:t>
-            </a:r>
-          </a:p>
-          <a:p>
-            <a:pPr lvl="0"/>
-            <a:r>
-              <a:rPr/>
-              <a:t>The adjustment helps “level the playing field” by estimating what each group’s mean would be if they all had the same value of the covariate</a:t>
+              <a:t>The core purpose of ANCOVA is to make this adjustment and important because:</a:t>
+            </a:r>
+          </a:p>
+          <a:p>
+            <a:pPr lvl="1"/>
+            <a:r>
+              <a:rPr/>
+              <a:t>When groups differ in their covariate values (as they often do in observational studies or even in exps with random assignment), comparing raw means can be misleading</a:t>
+            </a:r>
+          </a:p>
+          <a:p>
+            <a:pPr lvl="1"/>
+            <a:r>
+              <a:rPr/>
+              <a:t>Adjustment helps “level the playing field” by estimating what each group’s mean would be if all had same value of covariate</a:t>
             </a:r>
           </a:p>
         </p:txBody>
@@ -13519,8 +13538,8 @@
         </p:blipFill>
         <p:spPr bwMode="auto">
           <a:xfrm>
-            <a:off x="1409700" y="609600"/>
-            <a:ext cx="6261100" cy="3911600"/>
+            <a:off x="1358900" y="609600"/>
+            <a:ext cx="6350000" cy="3911600"/>
           </a:xfrm>
           <a:prstGeom prst="rect">
             <a:avLst/>

</xml_diff>